<commit_message>
docs: describe the Docker Engine toolchain and the newest stable pins
- prerequisites: Docker Engine (docker-ce from Docker's repo, context
  default, docker compose plugin) on Fedora/RHEL; no Docker Desktop, no
  other OS; Prometheus on host 19090
- ch.29/30: minikube on the docker driver with containerd, images via
  docker build + minikube image load, NodePorts 30888/30300 published at
  profile creation, Istio 1.31.1, otel-lgtm 0.36.0 collector changes
- ch.10/28/31 and others: Testcontainers on the Docker socket, Apicurio
  3.3.3 (health on :9000, rule violation now HTTP 400), Postgres 18.6,
  Kafka 4.3.1, Spring Boot 4.1.1, UBI 10 images
- dated DRQ-077 notes on ch.01/30/33; recorded runs and verification
  footers stay as captured
- README stack table and paths; regenerated the two figures that named
  podman; rebuilt the two 201 decks with the new version tables
</commit_message>
<xml_diff>
--- a/presentation/modernizing-201-quarkus-camel/Modernizing-201-Quarkus-Camel-r1.0.pptx
+++ b/presentation/modernizing-201-quarkus-camel/Modernizing-201-Quarkus-Camel-r1.0.pptx
@@ -3980,7 +3980,7 @@
           <a:p>
             <a:r>
               <a:rPr lang="en-US" dirty="0"/>
-              <a:t>The pinned versions, for reproducibility — these drift, so re-check them against the repository before quoting them. JDK 25 is the baseline, with both the JVM and the AOT-cache path in play. Quarkus 3.40.1 is the platform BOM shared by every service, which is what keeps the extension versions aligned. Camel 4.2x arrives through camel-quarkus. Spring Boot 3.5 is the monolith and the Phase A compatibility bridge. Kafka in KRaft mode is the event backbone; PostgreSQL holds one schema per service plus the outbox tables; Apicurio provides the Avro registry for contract-first events; and Mandrel is the native-image builder. The general 201 and the book carry the full matrix with the per-service specifics.</a:t>
+              <a:t>The pinned versions, for reproducibility — these drift, so re-check them against the repository before quoting them. JDK 25 is the baseline, with both the JVM and the AOT-cache path in play. Quarkus 3.40.1 is the platform BOM shared by every service, which is what keeps the extension versions aligned. Camel 4.22 arrives through camel-quarkus. Spring Boot 4.1 runs the frozen monolith shell (it was built on 3.5) and 3.5 was the Phase A compatibility bridge. Kafka in KRaft mode is the event backbone; PostgreSQL holds one schema per service plus the outbox tables; Apicurio provides the Avro registry for contract-first events; and Mandrel is the native-image builder. The general 201 and the book carry the full matrix with the per-service specifics.</a:t>
             </a:r>
             <a:endParaRPr lang="en-US" dirty="0"/>
           </a:p>
@@ -4156,7 +4156,7 @@
           <a:p>
             <a:r>
               <a:rPr lang="en-US" dirty="0"/>
-              <a:t>To close: this deck was the framework lens, and the best next step is the code it points at. Everything shown is a real file in the repository — the edge router, the saga route, the extension lists, the messaging configuration — and all of it runs on Podman for development and minikube for the Kubernetes chapters. The book carries the full narrative, chapter by chapter, each with a runnable example and a verification footer. The other two decks cover the parts this one assumed: the 101 for the ideas and the general 201 for the whole migration. And the most practical entry point is the capability map a few slides back — find the service that matches the problem in front of you and read that module first.</a:t>
+              <a:t>To close: this deck was the framework lens, and the best next step is the code it points at. Everything shown is a real file in the repository — the edge router, the saga route, the extension lists, the messaging configuration — and all of it runs on Docker Engine for development and minikube for the Kubernetes chapters. The book carries the full narrative, chapter by chapter, each with a runnable example and a verification footer. The other two decks cover the parts this one assumed: the 101 for the ideas and the general 201 for the whole migration. And the most practical entry point is the capability map a few slides back — find the service that matches the problem in front of you and read that module first.</a:t>
             </a:r>
             <a:endParaRPr lang="en-US" dirty="0"/>
           </a:p>
@@ -28365,7 +28365,7 @@
                           <a:ea typeface="Red Hat Mono" pitchFamily="34" charset="-122"/>
                           <a:cs typeface="Red Hat Mono" pitchFamily="34" charset="-120"/>
                         </a:rPr>
-                        <a:t>Camel 4.2x</a:t>
+                        <a:t>Camel 4.22</a:t>
                       </a:r>
                       <a:endParaRPr lang="en-US" sz="1500" dirty="0">
                         <a:latin typeface="Red Hat Mono" charset="0"/>
@@ -28562,7 +28562,7 @@
                           <a:ea typeface="Red Hat Mono" pitchFamily="34" charset="-122"/>
                           <a:cs typeface="Red Hat Mono" pitchFamily="34" charset="-120"/>
                         </a:rPr>
-                        <a:t>Spring Boot 3.5</a:t>
+                        <a:t>Spring Boot 4.1</a:t>
                       </a:r>
                       <a:endParaRPr lang="en-US" sz="1500" dirty="0">
                         <a:latin typeface="Red Hat Mono" charset="0"/>
@@ -28759,7 +28759,7 @@
                           <a:ea typeface="Red Hat Mono" pitchFamily="34" charset="-122"/>
                           <a:cs typeface="Red Hat Mono" pitchFamily="34" charset="-120"/>
                         </a:rPr>
-                        <a:t>Kafka 3.8 (KRaft)</a:t>
+                        <a:t>Kafka 4.3 (KRaft)</a:t>
                       </a:r>
                       <a:endParaRPr lang="en-US" sz="1500" dirty="0">
                         <a:latin typeface="Red Hat Mono" charset="0"/>
@@ -28956,7 +28956,7 @@
                           <a:ea typeface="Red Hat Mono" pitchFamily="34" charset="-122"/>
                           <a:cs typeface="Red Hat Mono" pitchFamily="34" charset="-120"/>
                         </a:rPr>
-                        <a:t>PostgreSQL</a:t>
+                        <a:t>PostgreSQL 18</a:t>
                       </a:r>
                       <a:endParaRPr lang="en-US" sz="1500" dirty="0">
                         <a:latin typeface="Red Hat Mono" charset="0"/>
@@ -29153,7 +29153,7 @@
                           <a:ea typeface="Red Hat Mono" pitchFamily="34" charset="-122"/>
                           <a:cs typeface="Red Hat Mono" pitchFamily="34" charset="-120"/>
                         </a:rPr>
-                        <a:t>Apicurio 3.1.7</a:t>
+                        <a:t>Apicurio 3.3.3</a:t>
                       </a:r>
                       <a:endParaRPr lang="en-US" sz="1500" dirty="0">
                         <a:latin typeface="Red Hat Mono" charset="0"/>
@@ -30299,7 +30299,7 @@
                 <a:ea typeface="Red Hat Text" pitchFamily="34" charset="-122"/>
                 <a:cs typeface="Red Hat Text" pitchFamily="34" charset="-120"/>
               </a:rPr>
-              <a:t> — every snippet here is a real file — the routes, the extensions, the messaging wiring, runnable on Podman and minikube.</a:t>
+              <a:t> — every snippet here is a real file — the routes, the extensions, the messaging wiring, runnable on Docker Engine and minikube.</a:t>
             </a:r>
             <a:endParaRPr lang="en-US" sz="1600" dirty="0"/>
           </a:p>

</xml_diff>